<commit_message>
Regenerate Ocean investor, leadership and diligence decks from shared recipes
</commit_message>
<xml_diff>
--- a/output/pptx/ocean-mobility-energy-investor.pptx
+++ b/output/pptx/ocean-mobility-energy-investor.pptx
@@ -1397,7 +1397,7 @@
           <a:p>
             <a:r>
               <a:rPr lang="en-US" dirty="0"/>
-              <a:t/>
+              <a:t>Ocean leadership confirmed on 27 Sep 2026 that the supplied drone photo is a real Ocean project. No project size, customer or performance claim is inferred from it.</a:t>
             </a:r>
             <a:endParaRPr lang="en-US" dirty="0"/>
           </a:p>
@@ -2212,7 +2212,7 @@
       </p:grpSpPr>
       <p:pic>
         <p:nvPicPr>
-          <p:cNvPr id="2" name="ocean:texture" descr="/home/user/workspace/audit/repo/assets/textures/tex_deck_sage.png">    </p:cNvPr>
+          <p:cNvPr id="2" name="ocean:texture" descr="C:\Users\sctho\OneDrive\Documents\ChatGPT\ocean-brand-system\assets\textures\tex_deck_sage.png">    </p:cNvPr>
           <p:cNvPicPr>
             <a:picLocks noChangeAspect="1"/>
           </p:cNvPicPr>
@@ -2294,7 +2294,7 @@
       </p:sp>
       <p:pic>
         <p:nvPicPr>
-          <p:cNvPr id="4" name="ocean:logo-vertical" descr="/home/user/workspace/audit/repo/assets/logos/png/logo_vertical_honeydew.png">    </p:cNvPr>
+          <p:cNvPr id="4" name="ocean:logo-vertical" descr="C:\Users\sctho\OneDrive\Documents\ChatGPT\ocean-brand-system\assets\logos\png\logo_vertical_honeydew.png">    </p:cNvPr>
           <p:cNvPicPr>
             <a:picLocks noChangeAspect="1"/>
           </p:cNvPicPr>
@@ -2771,7 +2771,7 @@
       </p:grpSpPr>
       <p:pic>
         <p:nvPicPr>
-          <p:cNvPr id="2" name="ocean:environment" descr="/home/user/workspace/audit/repo/assets/environments/env_olive_map_dark.jpg">    </p:cNvPr>
+          <p:cNvPr id="2" name="ocean:environment" descr="C:\Users\sctho\OneDrive\Documents\ChatGPT\ocean-brand-system\assets\environments\env_olive_map_dark.jpg">    </p:cNvPr>
           <p:cNvPicPr>
             <a:picLocks noChangeAspect="1"/>
           </p:cNvPicPr>
@@ -2795,7 +2795,7 @@
       </p:pic>
       <p:pic>
         <p:nvPicPr>
-          <p:cNvPr id="3" name="ocean:logo-graphic" descr="/home/user/workspace/audit/repo/assets/logos/png/logo_graphic_honeydew.png">    </p:cNvPr>
+          <p:cNvPr id="3" name="ocean:logo-graphic" descr="C:\Users\sctho\OneDrive\Documents\ChatGPT\ocean-brand-system\assets\logos\png\logo_graphic_honeydew.png">    </p:cNvPr>
           <p:cNvPicPr>
             <a:picLocks noChangeAspect="1"/>
           </p:cNvPicPr>
@@ -3081,7 +3081,7 @@
       </p:sp>
       <p:pic>
         <p:nvPicPr>
-          <p:cNvPr id="3" name="ocean:logo-horizontal" descr="/home/user/workspace/audit/repo/assets/logos/png/logo_horizontal_olive.png">    </p:cNvPr>
+          <p:cNvPr id="3" name="ocean:logo-horizontal" descr="C:\Users\sctho\OneDrive\Documents\ChatGPT\ocean-brand-system\assets\logos\png\logo_horizontal_olive.png">    </p:cNvPr>
           <p:cNvPicPr>
             <a:picLocks noChangeAspect="1"/>
           </p:cNvPicPr>
@@ -4868,7 +4868,7 @@
       </p:sp>
       <p:pic>
         <p:nvPicPr>
-          <p:cNvPr id="3" name="ocean:logo-horizontal" descr="/home/user/workspace/audit/repo/assets/logos/png/logo_horizontal_olive.png">    </p:cNvPr>
+          <p:cNvPr id="3" name="ocean:logo-horizontal" descr="C:\Users\sctho\OneDrive\Documents\ChatGPT\ocean-brand-system\assets\logos\png\logo_horizontal_olive.png">    </p:cNvPr>
           <p:cNvPicPr>
             <a:picLocks noChangeAspect="1"/>
           </p:cNvPicPr>
@@ -6554,7 +6554,7 @@
       </p:grpSpPr>
       <p:pic>
         <p:nvPicPr>
-          <p:cNvPr id="2" name="ocean:texture" descr="/home/user/workspace/audit/repo/assets/textures/tex_deck_blackmoss.png">    </p:cNvPr>
+          <p:cNvPr id="2" name="ocean:texture" descr="C:\Users\sctho\OneDrive\Documents\ChatGPT\ocean-brand-system\assets\textures\tex_deck_blackmoss.png">    </p:cNvPr>
           <p:cNvPicPr>
             <a:picLocks noChangeAspect="1"/>
           </p:cNvPicPr>
@@ -6578,7 +6578,7 @@
       </p:pic>
       <p:pic>
         <p:nvPicPr>
-          <p:cNvPr id="4" name="ocean:logo-graphic" descr="/home/user/workspace/audit/repo/assets/logos/png/logo_graphic_honeydew.png">    </p:cNvPr>
+          <p:cNvPr id="4" name="ocean:logo-graphic" descr="C:\Users\sctho\OneDrive\Documents\ChatGPT\ocean-brand-system\assets\logos\png\logo_graphic_honeydew.png">    </p:cNvPr>
           <p:cNvPicPr>
             <a:picLocks noChangeAspect="1"/>
           </p:cNvPicPr>
@@ -7035,7 +7035,7 @@
       </p:sp>
       <p:pic>
         <p:nvPicPr>
-          <p:cNvPr id="3" name="ocean:logo-horizontal" descr="/home/user/workspace/audit/repo/assets/logos/png/logo_horizontal_blackmoss.png">    </p:cNvPr>
+          <p:cNvPr id="3" name="ocean:logo-horizontal" descr="C:\Users\sctho\OneDrive\Documents\ChatGPT\ocean-brand-system\assets\logos\png\logo_horizontal_blackmoss.png">    </p:cNvPr>
           <p:cNvPicPr>
             <a:picLocks noChangeAspect="1"/>
           </p:cNvPicPr>
@@ -9165,7 +9165,7 @@
       </p:grpSpPr>
       <p:pic>
         <p:nvPicPr>
-          <p:cNvPr id="2" name="ocean:logo-graphic" descr="/home/user/workspace/audit/repo/assets/logos/png/logo_graphic_blackmoss.png">    </p:cNvPr>
+          <p:cNvPr id="2" name="ocean:logo-graphic" descr="C:\Users\sctho\OneDrive\Documents\ChatGPT\ocean-brand-system\assets\logos\png\logo_graphic_blackmoss.png">    </p:cNvPr>
           <p:cNvPicPr>
             <a:picLocks noChangeAspect="1"/>
           </p:cNvPicPr>
@@ -9641,7 +9641,7 @@
       </p:grpSpPr>
       <p:pic>
         <p:nvPicPr>
-          <p:cNvPr id="2" name="ocean:texture" descr="/home/user/workspace/audit/repo/assets/textures/tex_deck_sage.png">    </p:cNvPr>
+          <p:cNvPr id="2" name="ocean:texture" descr="C:\Users\sctho\OneDrive\Documents\ChatGPT\ocean-brand-system\assets\textures\tex_deck_sage.png">    </p:cNvPr>
           <p:cNvPicPr>
             <a:picLocks noChangeAspect="1"/>
           </p:cNvPicPr>
@@ -9665,7 +9665,7 @@
       </p:pic>
       <p:pic>
         <p:nvPicPr>
-          <p:cNvPr id="3" name="ocean:logo-vertical" descr="/home/user/workspace/audit/repo/assets/logos/png/logo_vertical_honeydew.png">    </p:cNvPr>
+          <p:cNvPr id="3" name="ocean:logo-vertical" descr="C:\Users\sctho\OneDrive\Documents\ChatGPT\ocean-brand-system\assets\logos\png\logo_vertical_honeydew.png">    </p:cNvPr>
           <p:cNvPicPr>
             <a:picLocks noChangeAspect="1"/>
           </p:cNvPicPr>
@@ -9721,7 +9721,7 @@
       </p:grpSpPr>
       <p:pic>
         <p:nvPicPr>
-          <p:cNvPr id="2" name="ocean:logo-horizontal" descr="/home/user/workspace/audit/repo/assets/logos/png/logo_horizontal_blackmoss.png">    </p:cNvPr>
+          <p:cNvPr id="2" name="ocean:logo-horizontal" descr="C:\Users\sctho\OneDrive\Documents\ChatGPT\ocean-brand-system\assets\logos\png\logo_horizontal_blackmoss.png">    </p:cNvPr>
           <p:cNvPicPr>
             <a:picLocks noChangeAspect="1"/>
           </p:cNvPicPr>
@@ -10589,7 +10589,7 @@
       </p:grpSpPr>
       <p:pic>
         <p:nvPicPr>
-          <p:cNvPr id="2" name="ocean:environment" descr="/home/user/workspace/audit/repo/assets/environments/env_peacock_map_light.jpg">    </p:cNvPr>
+          <p:cNvPr id="2" name="ocean:environment" descr="C:\Users\sctho\OneDrive\Documents\ChatGPT\ocean-brand-system\assets\environments\env_peacock_map_light.jpg">    </p:cNvPr>
           <p:cNvPicPr>
             <a:picLocks noChangeAspect="1"/>
           </p:cNvPicPr>
@@ -10613,7 +10613,7 @@
       </p:pic>
       <p:pic>
         <p:nvPicPr>
-          <p:cNvPr id="3" name="ocean:logo-graphic" descr="/home/user/workspace/audit/repo/assets/logos/png/logo_graphic_honeydew.png">    </p:cNvPr>
+          <p:cNvPr id="3" name="ocean:logo-graphic" descr="C:\Users\sctho\OneDrive\Documents\ChatGPT\ocean-brand-system\assets\logos\png\logo_graphic_honeydew.png">    </p:cNvPr>
           <p:cNvPicPr>
             <a:picLocks noChangeAspect="1"/>
           </p:cNvPicPr>
@@ -10857,7 +10857,7 @@
       </p:grpSpPr>
       <p:sp>
         <p:nvSpPr>
-          <p:cNvPr id="2" name="ocean:header"/>
+          <p:cNvPr id="3" name="ocean:header"/>
           <p:cNvSpPr/>
           <p:nvPr/>
         </p:nvSpPr>
@@ -10879,7 +10879,7 @@
       </p:sp>
       <p:pic>
         <p:nvPicPr>
-          <p:cNvPr id="3" name="ocean:logo-horizontal" descr="/home/user/workspace/audit/repo/assets/logos/png/logo_horizontal_peacock.png">    </p:cNvPr>
+          <p:cNvPr id="4" name="ocean:logo-horizontal" descr="C:\Users\sctho\OneDrive\Documents\ChatGPT\ocean-brand-system\assets\logos\png\logo_horizontal_peacock.png">    </p:cNvPr>
           <p:cNvPicPr>
             <a:picLocks noChangeAspect="1"/>
           </p:cNvPicPr>
@@ -10903,7 +10903,7 @@
       </p:pic>
       <p:sp>
         <p:nvSpPr>
-          <p:cNvPr id="4" name="Shape 1"/>
+          <p:cNvPr id="5" name="Shape 1"/>
           <p:cNvSpPr/>
           <p:nvPr/>
         </p:nvSpPr>
@@ -10926,7 +10926,7 @@
       </p:sp>
       <p:sp>
         <p:nvSpPr>
-          <p:cNvPr id="5" name="ocean:header"/>
+          <p:cNvPr id="6" name="ocean:header"/>
           <p:cNvSpPr/>
           <p:nvPr/>
         </p:nvSpPr>
@@ -10968,7 +10968,7 @@
       </p:sp>
       <p:sp>
         <p:nvSpPr>
-          <p:cNvPr id="6" name="ocean:header"/>
+          <p:cNvPr id="7" name="ocean:header"/>
           <p:cNvSpPr/>
           <p:nvPr/>
         </p:nvSpPr>
@@ -11010,7 +11010,7 @@
       </p:sp>
       <p:sp>
         <p:nvSpPr>
-          <p:cNvPr id="7" name="Shape 4"/>
+          <p:cNvPr id="8" name="Shape 4"/>
           <p:cNvSpPr/>
           <p:nvPr/>
         </p:nvSpPr>
@@ -11033,7 +11033,7 @@
       </p:sp>
       <p:sp>
         <p:nvSpPr>
-          <p:cNvPr id="8" name="Shape 5"/>
+          <p:cNvPr id="9" name="Shape 5"/>
           <p:cNvSpPr/>
           <p:nvPr/>
         </p:nvSpPr>
@@ -11058,7 +11058,7 @@
       </p:sp>
       <p:sp>
         <p:nvSpPr>
-          <p:cNvPr id="9" name="ocean:header"/>
+          <p:cNvPr id="10" name="ocean:header"/>
           <p:cNvSpPr/>
           <p:nvPr/>
         </p:nvSpPr>
@@ -11100,7 +11100,7 @@
       </p:sp>
       <p:sp>
         <p:nvSpPr>
-          <p:cNvPr id="10" name="ocean:header"/>
+          <p:cNvPr id="11" name="ocean:header"/>
           <p:cNvSpPr/>
           <p:nvPr/>
         </p:nvSpPr>
@@ -11142,7 +11142,7 @@
       </p:sp>
       <p:sp>
         <p:nvSpPr>
-          <p:cNvPr id="11" name="ocean:header"/>
+          <p:cNvPr id="12" name="ocean:header"/>
           <p:cNvSpPr/>
           <p:nvPr/>
         </p:nvSpPr>
@@ -11184,7 +11184,7 @@
       </p:sp>
       <p:sp>
         <p:nvSpPr>
-          <p:cNvPr id="12" name="ocean:header"/>
+          <p:cNvPr id="13" name="ocean:header"/>
           <p:cNvSpPr/>
           <p:nvPr/>
         </p:nvSpPr>
@@ -11226,7 +11226,7 @@
       </p:sp>
       <p:sp>
         <p:nvSpPr>
-          <p:cNvPr id="13" name="Shape 10"/>
+          <p:cNvPr id="14" name="Shape 10"/>
           <p:cNvSpPr/>
           <p:nvPr/>
         </p:nvSpPr>
@@ -11249,7 +11249,7 @@
       </p:sp>
       <p:sp>
         <p:nvSpPr>
-          <p:cNvPr id="14" name="ocean:header"/>
+          <p:cNvPr id="15" name="ocean:header"/>
           <p:cNvSpPr/>
           <p:nvPr/>
         </p:nvSpPr>
@@ -11291,7 +11291,7 @@
       </p:sp>
       <p:sp>
         <p:nvSpPr>
-          <p:cNvPr id="15" name="ocean:header"/>
+          <p:cNvPr id="16" name="ocean:header"/>
           <p:cNvSpPr/>
           <p:nvPr/>
         </p:nvSpPr>
@@ -11333,7 +11333,7 @@
       </p:sp>
       <p:sp>
         <p:nvSpPr>
-          <p:cNvPr id="16" name="Shape 13"/>
+          <p:cNvPr id="17" name="Shape 13"/>
           <p:cNvSpPr/>
           <p:nvPr/>
         </p:nvSpPr>
@@ -11356,7 +11356,7 @@
       </p:sp>
       <p:sp>
         <p:nvSpPr>
-          <p:cNvPr id="17" name="Shape 14"/>
+          <p:cNvPr id="18" name="Shape 14"/>
           <p:cNvSpPr/>
           <p:nvPr/>
         </p:nvSpPr>
@@ -11381,7 +11381,7 @@
       </p:sp>
       <p:sp>
         <p:nvSpPr>
-          <p:cNvPr id="18" name="ocean:header"/>
+          <p:cNvPr id="19" name="ocean:header"/>
           <p:cNvSpPr/>
           <p:nvPr/>
         </p:nvSpPr>
@@ -11423,7 +11423,7 @@
       </p:sp>
       <p:sp>
         <p:nvSpPr>
-          <p:cNvPr id="19" name="Shape 16"/>
+          <p:cNvPr id="20" name="Shape 16"/>
           <p:cNvSpPr/>
           <p:nvPr/>
         </p:nvSpPr>
@@ -11446,7 +11446,7 @@
       </p:sp>
       <p:sp>
         <p:nvSpPr>
-          <p:cNvPr id="20" name="ocean:header"/>
+          <p:cNvPr id="21" name="ocean:header"/>
           <p:cNvSpPr/>
           <p:nvPr/>
         </p:nvSpPr>
@@ -11488,7 +11488,7 @@
       </p:sp>
       <p:sp>
         <p:nvSpPr>
-          <p:cNvPr id="21" name="Shape 18"/>
+          <p:cNvPr id="22" name="Shape 18"/>
           <p:cNvSpPr/>
           <p:nvPr/>
         </p:nvSpPr>
@@ -11511,7 +11511,7 @@
       </p:sp>
       <p:sp>
         <p:nvSpPr>
-          <p:cNvPr id="22" name="ocean:header"/>
+          <p:cNvPr id="23" name="ocean:header"/>
           <p:cNvSpPr/>
           <p:nvPr/>
         </p:nvSpPr>
@@ -11553,7 +11553,7 @@
       </p:sp>
       <p:sp>
         <p:nvSpPr>
-          <p:cNvPr id="23" name="Shape 20"/>
+          <p:cNvPr id="24" name="Shape 20"/>
           <p:cNvSpPr/>
           <p:nvPr/>
         </p:nvSpPr>
@@ -11576,7 +11576,7 @@
       </p:sp>
       <p:sp>
         <p:nvSpPr>
-          <p:cNvPr id="24" name="ocean:header"/>
+          <p:cNvPr id="25" name="ocean:header"/>
           <p:cNvSpPr/>
           <p:nvPr/>
         </p:nvSpPr>
@@ -11618,7 +11618,7 @@
       </p:sp>
       <p:sp>
         <p:nvSpPr>
-          <p:cNvPr id="25" name="ocean:label"/>
+          <p:cNvPr id="26" name="ocean:label"/>
           <p:cNvSpPr/>
           <p:nvPr/>
         </p:nvSpPr>
@@ -11660,7 +11660,7 @@
       </p:sp>
       <p:sp>
         <p:nvSpPr>
-          <p:cNvPr id="26" name="ocean:headline"/>
+          <p:cNvPr id="27" name="ocean:headline"/>
           <p:cNvSpPr/>
           <p:nvPr/>
         </p:nvSpPr>
@@ -11722,7 +11722,7 @@
       </p:sp>
       <p:sp>
         <p:nvSpPr>
-          <p:cNvPr id="27" name="ocean:lede"/>
+          <p:cNvPr id="28" name="ocean:lede"/>
           <p:cNvSpPr/>
           <p:nvPr/>
         </p:nvSpPr>
@@ -11804,7 +11804,7 @@
       </p:sp>
       <p:sp>
         <p:nvSpPr>
-          <p:cNvPr id="28" name="Shape 25"/>
+          <p:cNvPr id="29" name="Shape 25"/>
           <p:cNvSpPr/>
           <p:nvPr/>
         </p:nvSpPr>
@@ -11827,7 +11827,7 @@
       </p:sp>
       <p:pic>
         <p:nvPicPr>
-          <p:cNvPr id="29" name="ocean:photo" descr="/home/user/workspace/audit/repo/output/.cache/fit/solar-carport-campus-c5892794287ed22f.jpg">    </p:cNvPr>
+          <p:cNvPr id="30" name="ocean:photo" descr="C:\Users\sctho\OneDrive\Documents\ChatGPT\ocean-brand-system\output\.cache\fit\solar-carport-campus-041d77b11b2a487a.jpg">    </p:cNvPr>
           <p:cNvPicPr>
             <a:picLocks noChangeAspect="1"/>
           </p:cNvPicPr>
@@ -11851,7 +11851,7 @@
       </p:pic>
       <p:sp>
         <p:nvSpPr>
-          <p:cNvPr id="30" name="Shape 26"/>
+          <p:cNvPr id="31" name="Shape 26"/>
           <p:cNvSpPr/>
           <p:nvPr/>
         </p:nvSpPr>
@@ -11876,7 +11876,7 @@
       </p:sp>
       <p:sp>
         <p:nvSpPr>
-          <p:cNvPr id="31" name="ocean:frame"/>
+          <p:cNvPr id="32" name="ocean:frame"/>
           <p:cNvSpPr/>
           <p:nvPr/>
         </p:nvSpPr>
@@ -11937,7 +11937,7 @@
       </p:sp>
       <p:sp>
         <p:nvSpPr>
-          <p:cNvPr id="32" name="Shape 28"/>
+          <p:cNvPr id="33" name="Shape 28"/>
           <p:cNvSpPr/>
           <p:nvPr/>
         </p:nvSpPr>
@@ -11962,7 +11962,7 @@
       </p:sp>
       <p:sp>
         <p:nvSpPr>
-          <p:cNvPr id="33" name="ocean:label"/>
+          <p:cNvPr id="34" name="ocean:label"/>
           <p:cNvSpPr/>
           <p:nvPr/>
         </p:nvSpPr>
@@ -12004,7 +12004,7 @@
       </p:sp>
       <p:sp>
         <p:nvSpPr>
-          <p:cNvPr id="34" name="ocean:body"/>
+          <p:cNvPr id="35" name="ocean:body"/>
           <p:cNvSpPr/>
           <p:nvPr/>
         </p:nvSpPr>
@@ -12046,7 +12046,7 @@
       </p:sp>
       <p:sp>
         <p:nvSpPr>
-          <p:cNvPr id="35" name="ocean:frame"/>
+          <p:cNvPr id="36" name="ocean:frame"/>
           <p:cNvSpPr/>
           <p:nvPr/>
         </p:nvSpPr>
@@ -12107,7 +12107,7 @@
       </p:sp>
       <p:sp>
         <p:nvSpPr>
-          <p:cNvPr id="36" name="Shape 32"/>
+          <p:cNvPr id="37" name="Shape 32"/>
           <p:cNvSpPr/>
           <p:nvPr/>
         </p:nvSpPr>
@@ -12132,7 +12132,7 @@
       </p:sp>
       <p:sp>
         <p:nvSpPr>
-          <p:cNvPr id="37" name="Shape 33"/>
+          <p:cNvPr id="38" name="Shape 33"/>
           <p:cNvSpPr/>
           <p:nvPr/>
         </p:nvSpPr>
@@ -12157,7 +12157,7 @@
       </p:sp>
       <p:sp>
         <p:nvSpPr>
-          <p:cNvPr id="38" name="ocean:label"/>
+          <p:cNvPr id="39" name="ocean:label"/>
           <p:cNvSpPr/>
           <p:nvPr/>
         </p:nvSpPr>
@@ -12199,7 +12199,7 @@
       </p:sp>
       <p:sp>
         <p:nvSpPr>
-          <p:cNvPr id="39" name="ocean:body"/>
+          <p:cNvPr id="40" name="ocean:body"/>
           <p:cNvSpPr/>
           <p:nvPr/>
         </p:nvSpPr>
@@ -12241,7 +12241,7 @@
       </p:sp>
       <p:sp>
         <p:nvSpPr>
-          <p:cNvPr id="40" name="ocean:frame"/>
+          <p:cNvPr id="41" name="ocean:frame"/>
           <p:cNvSpPr/>
           <p:nvPr/>
         </p:nvSpPr>
@@ -12302,7 +12302,7 @@
       </p:sp>
       <p:sp>
         <p:nvSpPr>
-          <p:cNvPr id="41" name="Shape 37"/>
+          <p:cNvPr id="42" name="Shape 37"/>
           <p:cNvSpPr/>
           <p:nvPr/>
         </p:nvSpPr>
@@ -12327,7 +12327,7 @@
       </p:sp>
       <p:sp>
         <p:nvSpPr>
-          <p:cNvPr id="42" name="Shape 38"/>
+          <p:cNvPr id="43" name="Shape 38"/>
           <p:cNvSpPr/>
           <p:nvPr/>
         </p:nvSpPr>
@@ -12352,7 +12352,7 @@
       </p:sp>
       <p:sp>
         <p:nvSpPr>
-          <p:cNvPr id="43" name="Shape 39"/>
+          <p:cNvPr id="44" name="Shape 39"/>
           <p:cNvSpPr/>
           <p:nvPr/>
         </p:nvSpPr>
@@ -12377,7 +12377,7 @@
       </p:sp>
       <p:sp>
         <p:nvSpPr>
-          <p:cNvPr id="44" name="ocean:label"/>
+          <p:cNvPr id="45" name="ocean:label"/>
           <p:cNvSpPr/>
           <p:nvPr/>
         </p:nvSpPr>
@@ -12419,7 +12419,7 @@
       </p:sp>
       <p:sp>
         <p:nvSpPr>
-          <p:cNvPr id="45" name="ocean:body"/>
+          <p:cNvPr id="46" name="ocean:body"/>
           <p:cNvSpPr/>
           <p:nvPr/>
         </p:nvSpPr>
@@ -12461,7 +12461,7 @@
       </p:sp>
       <p:sp>
         <p:nvSpPr>
-          <p:cNvPr id="46" name="ocean:body"/>
+          <p:cNvPr id="47" name="ocean:body"/>
           <p:cNvSpPr/>
           <p:nvPr/>
         </p:nvSpPr>
@@ -12495,7 +12495,7 @@
                 <a:ea typeface="Stack Sans Headline" pitchFamily="34" charset="-122"/>
                 <a:cs typeface="Stack Sans Headline" pitchFamily="34" charset="-120"/>
               </a:rPr>
-              <a:t>Representative image: solar parking structures on a corporate campus.</a:t>
+              <a:t>Ocean project photo: solar parking structures, DJI_0482</a:t>
             </a:r>
             <a:endParaRPr lang="en-US" sz="1200" dirty="0"/>
           </a:p>
@@ -12503,7 +12503,7 @@
       </p:sp>
       <p:sp>
         <p:nvSpPr>
-          <p:cNvPr id="47" name="ocean:footer"/>
+          <p:cNvPr id="48" name="ocean:footer"/>
           <p:cNvSpPr/>
           <p:nvPr/>
         </p:nvSpPr>
@@ -12599,7 +12599,7 @@
       </p:sp>
       <p:pic>
         <p:nvPicPr>
-          <p:cNvPr id="3" name="ocean:logo-horizontal" descr="/home/user/workspace/audit/repo/assets/logos/png/logo_horizontal_peacock.png">    </p:cNvPr>
+          <p:cNvPr id="3" name="ocean:logo-horizontal" descr="C:\Users\sctho\OneDrive\Documents\ChatGPT\ocean-brand-system\assets\logos\png\logo_horizontal_peacock.png">    </p:cNvPr>
           <p:cNvPicPr>
             <a:picLocks noChangeAspect="1"/>
           </p:cNvPicPr>
@@ -14310,7 +14310,7 @@
       </p:grpSpPr>
       <p:pic>
         <p:nvPicPr>
-          <p:cNvPr id="2" name="ocean:environment" descr="/home/user/workspace/audit/repo/assets/environments/env_sprig_map_light_soft.jpg">    </p:cNvPr>
+          <p:cNvPr id="2" name="ocean:environment" descr="C:\Users\sctho\OneDrive\Documents\ChatGPT\ocean-brand-system\assets\environments\env_sprig_map_light_soft.jpg">    </p:cNvPr>
           <p:cNvPicPr>
             <a:picLocks noChangeAspect="1"/>
           </p:cNvPicPr>
@@ -14334,7 +14334,7 @@
       </p:pic>
       <p:pic>
         <p:nvPicPr>
-          <p:cNvPr id="3" name="ocean:logo-graphic" descr="/home/user/workspace/audit/repo/assets/logos/png/logo_graphic_sage.png">    </p:cNvPr>
+          <p:cNvPr id="3" name="ocean:logo-graphic" descr="C:\Users\sctho\OneDrive\Documents\ChatGPT\ocean-brand-system\assets\logos\png\logo_graphic_sage.png">    </p:cNvPr>
           <p:cNvPicPr>
             <a:picLocks noChangeAspect="1"/>
           </p:cNvPicPr>
@@ -14558,7 +14558,7 @@
       </p:sp>
       <p:pic>
         <p:nvPicPr>
-          <p:cNvPr id="3" name="ocean:logo-horizontal" descr="/home/user/workspace/audit/repo/assets/logos/png/logo_horizontal_cedar.png">    </p:cNvPr>
+          <p:cNvPr id="3" name="ocean:logo-horizontal" descr="C:\Users\sctho\OneDrive\Documents\ChatGPT\ocean-brand-system\assets\logos\png\logo_horizontal_cedar.png">    </p:cNvPr>
           <p:cNvPicPr>
             <a:picLocks noChangeAspect="1"/>
           </p:cNvPicPr>
@@ -15486,7 +15486,7 @@
       </p:sp>
       <p:pic>
         <p:nvPicPr>
-          <p:cNvPr id="29" name="ocean:photo" descr="/home/user/workspace/audit/repo/output/.cache/fit/mobility-hub-15c8a0038a3749fc.jpg">    </p:cNvPr>
+          <p:cNvPr id="29" name="ocean:photo" descr="C:\Users\sctho\OneDrive\Documents\ChatGPT\ocean-brand-system\output\.cache\fit\mobility-hub-fafb5dd91e8cd0c4.jpg">    </p:cNvPr>
           <p:cNvPicPr>
             <a:picLocks noChangeAspect="1"/>
           </p:cNvPicPr>
@@ -16503,7 +16503,7 @@
       </p:sp>
       <p:pic>
         <p:nvPicPr>
-          <p:cNvPr id="3" name="ocean:logo-horizontal" descr="/home/user/workspace/audit/repo/assets/logos/png/logo_horizontal_cedar.png">    </p:cNvPr>
+          <p:cNvPr id="3" name="ocean:logo-horizontal" descr="C:\Users\sctho\OneDrive\Documents\ChatGPT\ocean-brand-system\assets\logos\png\logo_horizontal_cedar.png">    </p:cNvPr>
           <p:cNvPicPr>
             <a:picLocks noChangeAspect="1"/>
           </p:cNvPicPr>
@@ -18211,7 +18211,7 @@
       </p:sp>
       <p:pic>
         <p:nvPicPr>
-          <p:cNvPr id="3" name="ocean:logo-horizontal" descr="/home/user/workspace/audit/repo/assets/logos/png/logo_horizontal_cedar.png">    </p:cNvPr>
+          <p:cNvPr id="3" name="ocean:logo-horizontal" descr="C:\Users\sctho\OneDrive\Documents\ChatGPT\ocean-brand-system\assets\logos\png\logo_horizontal_cedar.png">    </p:cNvPr>
           <p:cNvPicPr>
             <a:picLocks noChangeAspect="1"/>
           </p:cNvPicPr>

</xml_diff>